<commit_message>
feat: D56 Terminology dictionary integration & stabilization
</commit_message>
<xml_diff>
--- a/docs/test/golden-outputs/p2-sinsa-r3/captures/sinsa_trading.pptx
+++ b/docs/test/golden-outputs/p2-sinsa-r3/captures/sinsa_trading.pptx
@@ -2021,7 +2021,7 @@
                 <a:ea typeface="맑은 고딕" pitchFamily="34" charset="-122"/>
                 <a:cs typeface="맑은 고딕" pitchFamily="34" charset="-120"/>
               </a:rPr>
-              <a:t>2026.09.24  |  담당자  |  CREDEAL</a:t>
+              <a:t>2026.09.29  |  담당자  |  CREDEAL</a:t>
             </a:r>
             <a:endParaRPr lang="en-US" sz="900" dirty="0"/>
           </a:p>
@@ -7428,231 +7428,11 @@
         <p:spPr>
           <a:xfrm>
             <a:off x="502920" y="1371600"/>
-            <a:ext cx="11057839" cy="1188720"/>
+            <a:ext cx="11057839" cy="4389120"/>
           </a:xfrm>
           <a:prstGeom prst="roundRect">
             <a:avLst>
-              <a:gd name="adj" fmla="val 6154"/>
-            </a:avLst>
-          </a:prstGeom>
-          <a:solidFill>
-            <a:srgbClr val="F7FAFC"/>
-          </a:solidFill>
-          <a:ln w="9525">
-            <a:solidFill>
-              <a:srgbClr val="CBD5E0"/>
-            </a:solidFill>
-            <a:prstDash val="solid"/>
-          </a:ln>
-        </p:spPr>
-      </p:sp>
-      <p:sp>
-        <p:nvSpPr>
-          <p:cNvPr id="7" name="Text 5"/>
-          <p:cNvSpPr/>
-          <p:nvPr/>
-        </p:nvSpPr>
-        <p:spPr>
-          <a:xfrm>
-            <a:off x="868680" y="1508760"/>
-            <a:ext cx="3200400" cy="822960"/>
-          </a:xfrm>
-          <a:prstGeom prst="rect">
-            <a:avLst/>
-          </a:prstGeom>
-          <a:noFill/>
-          <a:ln/>
-        </p:spPr>
-        <p:txBody>
-          <a:bodyPr wrap="square" rtlCol="0" anchor="ctr"/>
-          <a:lstStyle/>
-          <a:p>
-            <a:pPr indent="0" marL="0">
-              <a:buNone/>
-            </a:pPr>
-            <a:r>
-              <a:rPr lang="en-US" sz="1600" b="1" dirty="0">
-                <a:solidFill>
-                  <a:srgbClr val="132A3A"/>
-                </a:solidFill>
-                <a:latin typeface="맑은 고딕" pitchFamily="34" charset="0"/>
-                <a:ea typeface="맑은 고딕" pitchFamily="34" charset="-122"/>
-                <a:cs typeface="맑은 고딕" pitchFamily="34" charset="-120"/>
-              </a:rPr>
-              <a:t>표면 임대수익률  =</a:t>
-            </a:r>
-            <a:endParaRPr lang="en-US" sz="1600" dirty="0"/>
-          </a:p>
-        </p:txBody>
-      </p:sp>
-      <p:sp>
-        <p:nvSpPr>
-          <p:cNvPr id="8" name="Text 6"/>
-          <p:cNvSpPr/>
-          <p:nvPr/>
-        </p:nvSpPr>
-        <p:spPr>
-          <a:xfrm>
-            <a:off x="4343400" y="1508760"/>
-            <a:ext cx="4572000" cy="365760"/>
-          </a:xfrm>
-          <a:prstGeom prst="rect">
-            <a:avLst/>
-          </a:prstGeom>
-          <a:noFill/>
-          <a:ln/>
-        </p:spPr>
-        <p:txBody>
-          <a:bodyPr wrap="square" rtlCol="0" anchor="b"/>
-          <a:lstStyle/>
-          <a:p>
-            <a:pPr algn="ctr" indent="0" marL="0">
-              <a:buNone/>
-            </a:pPr>
-            <a:r>
-              <a:rPr lang="en-US" sz="1300" b="1" dirty="0">
-                <a:solidFill>
-                  <a:srgbClr val="132A3A"/>
-                </a:solidFill>
-                <a:latin typeface="맑은 고딕" pitchFamily="34" charset="0"/>
-                <a:ea typeface="맑은 고딕" pitchFamily="34" charset="-122"/>
-                <a:cs typeface="맑은 고딕" pitchFamily="34" charset="-120"/>
-              </a:rPr>
-              <a:t>연간 임대료 합계 (관리비 제외)</a:t>
-            </a:r>
-            <a:endParaRPr lang="en-US" sz="1300" dirty="0"/>
-          </a:p>
-        </p:txBody>
-      </p:sp>
-      <p:sp>
-        <p:nvSpPr>
-          <p:cNvPr id="9" name="Shape 7"/>
-          <p:cNvSpPr/>
-          <p:nvPr/>
-        </p:nvSpPr>
-        <p:spPr>
-          <a:xfrm>
-            <a:off x="4526280" y="1920240"/>
-            <a:ext cx="4206240" cy="0"/>
-          </a:xfrm>
-          <a:prstGeom prst="line">
-            <a:avLst/>
-          </a:prstGeom>
-          <a:noFill/>
-          <a:ln w="25400">
-            <a:solidFill>
-              <a:srgbClr val="B8860B"/>
-            </a:solidFill>
-            <a:prstDash val="solid"/>
-          </a:ln>
-        </p:spPr>
-      </p:sp>
-      <p:sp>
-        <p:nvSpPr>
-          <p:cNvPr id="10" name="Text 8"/>
-          <p:cNvSpPr/>
-          <p:nvPr/>
-        </p:nvSpPr>
-        <p:spPr>
-          <a:xfrm>
-            <a:off x="4343400" y="1965960"/>
-            <a:ext cx="4572000" cy="365760"/>
-          </a:xfrm>
-          <a:prstGeom prst="rect">
-            <a:avLst/>
-          </a:prstGeom>
-          <a:noFill/>
-          <a:ln/>
-        </p:spPr>
-        <p:txBody>
-          <a:bodyPr wrap="square" rtlCol="0" anchor="t"/>
-          <a:lstStyle/>
-          <a:p>
-            <a:pPr algn="ctr" indent="0" marL="0">
-              <a:buNone/>
-            </a:pPr>
-            <a:r>
-              <a:rPr lang="en-US" sz="1300" b="1" dirty="0">
-                <a:solidFill>
-                  <a:srgbClr val="132A3A"/>
-                </a:solidFill>
-                <a:latin typeface="맑은 고딕" pitchFamily="34" charset="0"/>
-                <a:ea typeface="맑은 고딕" pitchFamily="34" charset="-122"/>
-                <a:cs typeface="맑은 고딕" pitchFamily="34" charset="-120"/>
-              </a:rPr>
-              <a:t>매매가  −  승계 보증금 합계</a:t>
-            </a:r>
-            <a:endParaRPr lang="en-US" sz="1300" dirty="0"/>
-          </a:p>
-        </p:txBody>
-      </p:sp>
-      <p:sp>
-        <p:nvSpPr>
-          <p:cNvPr id="11" name="Text 9"/>
-          <p:cNvSpPr/>
-          <p:nvPr/>
-        </p:nvSpPr>
-        <p:spPr>
-          <a:xfrm>
-            <a:off x="8726119" y="1508760"/>
-            <a:ext cx="2697480" cy="822960"/>
-          </a:xfrm>
-          <a:prstGeom prst="rect">
-            <a:avLst/>
-          </a:prstGeom>
-          <a:noFill/>
-          <a:ln/>
-        </p:spPr>
-        <p:txBody>
-          <a:bodyPr wrap="square" rtlCol="0" anchor="ctr"/>
-          <a:lstStyle/>
-          <a:p>
-            <a:pPr algn="r" indent="0" marL="0">
-              <a:buNone/>
-            </a:pPr>
-            <a:r>
-              <a:rPr lang="en-US" sz="1100" b="1" dirty="0">
-                <a:solidFill>
-                  <a:srgbClr val="B8860B"/>
-                </a:solidFill>
-                <a:latin typeface="맑은 고딕" pitchFamily="34" charset="0"/>
-                <a:ea typeface="맑은 고딕" pitchFamily="34" charset="-122"/>
-                <a:cs typeface="맑은 고딕" pitchFamily="34" charset="-120"/>
-              </a:rPr>
-              <a:t>0만원</a:t>
-            </a:r>
-            <a:pPr algn="r" indent="0" marL="0">
-              <a:buNone/>
-            </a:pPr>
-            <a:r>
-              <a:rPr lang="en-US" sz="1100" dirty="0">
-                <a:solidFill>
-                  <a:srgbClr val="5B6B73"/>
-                </a:solidFill>
-                <a:latin typeface="맑은 고딕" pitchFamily="34" charset="0"/>
-                <a:ea typeface="맑은 고딕" pitchFamily="34" charset="-122"/>
-                <a:cs typeface="맑은 고딕" pitchFamily="34" charset="-120"/>
-              </a:rPr>
-              <a:t> ÷ (760.0억원 − 0만원)</a:t>
-            </a:r>
-            <a:endParaRPr lang="en-US" sz="1100" dirty="0"/>
-          </a:p>
-        </p:txBody>
-      </p:sp>
-      <p:sp>
-        <p:nvSpPr>
-          <p:cNvPr id="12" name="Shape 10"/>
-          <p:cNvSpPr/>
-          <p:nvPr/>
-        </p:nvSpPr>
-        <p:spPr>
-          <a:xfrm>
-            <a:off x="502920" y="2834640"/>
-            <a:ext cx="11057839" cy="3063240"/>
-          </a:xfrm>
-          <a:prstGeom prst="roundRect">
-            <a:avLst>
-              <a:gd name="adj" fmla="val 2388"/>
+              <a:gd name="adj" fmla="val 1667"/>
             </a:avLst>
           </a:prstGeom>
           <a:solidFill>
@@ -7668,36 +7448,36 @@
       </p:sp>
       <p:sp>
         <p:nvSpPr>
-          <p:cNvPr id="13" name="Shape 11"/>
-          <p:cNvSpPr/>
-          <p:nvPr/>
-        </p:nvSpPr>
-        <p:spPr>
-          <a:xfrm>
-            <a:off x="685800" y="3017520"/>
-            <a:ext cx="1280160" cy="329184"/>
+          <p:cNvPr id="7" name="Shape 5"/>
+          <p:cNvSpPr/>
+          <p:nvPr/>
+        </p:nvSpPr>
+        <p:spPr>
+          <a:xfrm>
+            <a:off x="731520" y="1600200"/>
+            <a:ext cx="10600639" cy="1005840"/>
           </a:xfrm>
           <a:prstGeom prst="roundRect">
             <a:avLst>
-              <a:gd name="adj" fmla="val 11111"/>
+              <a:gd name="adj" fmla="val 7273"/>
             </a:avLst>
           </a:prstGeom>
           <a:solidFill>
-            <a:srgbClr val="F3F6F7"/>
+            <a:srgbClr val="132A3A"/>
           </a:solidFill>
           <a:ln/>
         </p:spPr>
       </p:sp>
       <p:sp>
         <p:nvSpPr>
-          <p:cNvPr id="14" name="Text 12"/>
-          <p:cNvSpPr/>
-          <p:nvPr/>
-        </p:nvSpPr>
-        <p:spPr>
-          <a:xfrm>
-            <a:off x="685800" y="3017520"/>
-            <a:ext cx="1280160" cy="329184"/>
+          <p:cNvPr id="8" name="Text 6"/>
+          <p:cNvSpPr/>
+          <p:nvPr/>
+        </p:nvSpPr>
+        <p:spPr>
+          <a:xfrm>
+            <a:off x="960120" y="1600200"/>
+            <a:ext cx="2286000" cy="1005840"/>
           </a:xfrm>
           <a:prstGeom prst="rect">
             <a:avLst/>
@@ -7709,34 +7489,34 @@
           <a:bodyPr wrap="square" rtlCol="0" anchor="ctr"/>
           <a:lstStyle/>
           <a:p>
-            <a:pPr algn="ctr" indent="0" marL="0">
-              <a:buNone/>
-            </a:pPr>
-            <a:r>
-              <a:rPr lang="en-US" sz="1000" b="1" dirty="0">
-                <a:solidFill>
-                  <a:srgbClr val="132A3A"/>
-                </a:solidFill>
-                <a:latin typeface="맑은 고딕" pitchFamily="34" charset="0"/>
-                <a:ea typeface="맑은 고딕" pitchFamily="34" charset="-122"/>
-                <a:cs typeface="맑은 고딕" pitchFamily="34" charset="-120"/>
-              </a:rPr>
-              <a:t>As-Is (현재)</a:t>
-            </a:r>
-            <a:endParaRPr lang="en-US" sz="1000" dirty="0"/>
-          </a:p>
-        </p:txBody>
-      </p:sp>
-      <p:sp>
-        <p:nvSpPr>
-          <p:cNvPr id="15" name="Text 13"/>
-          <p:cNvSpPr/>
-          <p:nvPr/>
-        </p:nvSpPr>
-        <p:spPr>
-          <a:xfrm>
-            <a:off x="777240" y="3520440"/>
-            <a:ext cx="2743200" cy="402336"/>
+            <a:pPr indent="0" marL="0">
+              <a:buNone/>
+            </a:pPr>
+            <a:r>
+              <a:rPr lang="en-US" sz="1600" b="1" dirty="0">
+                <a:solidFill>
+                  <a:srgbClr val="FFFFFF"/>
+                </a:solidFill>
+                <a:latin typeface="맑은 고딕" pitchFamily="34" charset="0"/>
+                <a:ea typeface="맑은 고딕" pitchFamily="34" charset="-122"/>
+                <a:cs typeface="맑은 고딕" pitchFamily="34" charset="-120"/>
+              </a:rPr>
+              <a:t>수익률</a:t>
+            </a:r>
+            <a:endParaRPr lang="en-US" sz="1600" dirty="0"/>
+          </a:p>
+        </p:txBody>
+      </p:sp>
+      <p:sp>
+        <p:nvSpPr>
+          <p:cNvPr id="9" name="Text 7"/>
+          <p:cNvSpPr/>
+          <p:nvPr/>
+        </p:nvSpPr>
+        <p:spPr>
+          <a:xfrm>
+            <a:off x="8360359" y="1600200"/>
+            <a:ext cx="2743200" cy="1005840"/>
           </a:xfrm>
           <a:prstGeom prst="rect">
             <a:avLst/>
@@ -7748,73 +7528,34 @@
           <a:bodyPr wrap="square" rtlCol="0" anchor="ctr"/>
           <a:lstStyle/>
           <a:p>
-            <a:pPr indent="0" marL="0">
-              <a:buNone/>
-            </a:pPr>
-            <a:r>
-              <a:rPr lang="en-US" sz="1100" dirty="0">
-                <a:solidFill>
-                  <a:srgbClr val="5B6B73"/>
-                </a:solidFill>
-                <a:latin typeface="맑은 고딕" pitchFamily="34" charset="0"/>
-                <a:ea typeface="맑은 고딕" pitchFamily="34" charset="-122"/>
-                <a:cs typeface="맑은 고딕" pitchFamily="34" charset="-120"/>
-              </a:rPr>
-              <a:t>연간 임대료</a:t>
-            </a:r>
-            <a:endParaRPr lang="en-US" sz="1100" dirty="0"/>
-          </a:p>
-        </p:txBody>
-      </p:sp>
-      <p:sp>
-        <p:nvSpPr>
-          <p:cNvPr id="16" name="Text 14"/>
-          <p:cNvSpPr/>
-          <p:nvPr/>
-        </p:nvSpPr>
-        <p:spPr>
-          <a:xfrm>
-            <a:off x="9457639" y="3520440"/>
-            <a:ext cx="1828800" cy="402336"/>
-          </a:xfrm>
-          <a:prstGeom prst="rect">
-            <a:avLst/>
-          </a:prstGeom>
-          <a:noFill/>
-          <a:ln/>
-        </p:spPr>
-        <p:txBody>
-          <a:bodyPr wrap="square" rtlCol="0" anchor="ctr"/>
-          <a:lstStyle/>
-          <a:p>
             <a:pPr algn="r" indent="0" marL="0">
               <a:buNone/>
             </a:pPr>
             <a:r>
-              <a:rPr lang="en-US" sz="1200" b="1" dirty="0">
-                <a:solidFill>
-                  <a:srgbClr val="132A3A"/>
+              <a:rPr lang="en-US" sz="2800" b="1" dirty="0">
+                <a:solidFill>
+                  <a:srgbClr val="B8860B"/>
                 </a:solidFill>
                 <a:latin typeface="Arial" pitchFamily="34" charset="0"/>
                 <a:ea typeface="Arial" pitchFamily="34" charset="-122"/>
                 <a:cs typeface="Arial" pitchFamily="34" charset="-120"/>
               </a:rPr>
-              <a:t>0만원</a:t>
-            </a:r>
-            <a:endParaRPr lang="en-US" sz="1200" dirty="0"/>
-          </a:p>
-        </p:txBody>
-      </p:sp>
-      <p:sp>
-        <p:nvSpPr>
-          <p:cNvPr id="17" name="Text 15"/>
-          <p:cNvSpPr/>
-          <p:nvPr/>
-        </p:nvSpPr>
-        <p:spPr>
-          <a:xfrm>
-            <a:off x="777240" y="3922776"/>
-            <a:ext cx="2743200" cy="402336"/>
+              <a:t>0.00%</a:t>
+            </a:r>
+            <a:endParaRPr lang="en-US" sz="2800" dirty="0"/>
+          </a:p>
+        </p:txBody>
+      </p:sp>
+      <p:sp>
+        <p:nvSpPr>
+          <p:cNvPr id="10" name="Text 8"/>
+          <p:cNvSpPr/>
+          <p:nvPr/>
+        </p:nvSpPr>
+        <p:spPr>
+          <a:xfrm>
+            <a:off x="822960" y="2834640"/>
+            <a:ext cx="2743200" cy="347472"/>
           </a:xfrm>
           <a:prstGeom prst="rect">
             <a:avLst/>
@@ -7838,7 +7579,7 @@
                 <a:ea typeface="맑은 고딕" pitchFamily="34" charset="-122"/>
                 <a:cs typeface="맑은 고딕" pitchFamily="34" charset="-120"/>
               </a:rPr>
-              <a:t>승계 보증금</a:t>
+              <a:t>연간 임대수입</a:t>
             </a:r>
             <a:endParaRPr lang="en-US" sz="1100" dirty="0"/>
           </a:p>
@@ -7846,14 +7587,14 @@
       </p:sp>
       <p:sp>
         <p:nvSpPr>
-          <p:cNvPr id="18" name="Text 16"/>
-          <p:cNvSpPr/>
-          <p:nvPr/>
-        </p:nvSpPr>
-        <p:spPr>
-          <a:xfrm>
-            <a:off x="9457639" y="3922776"/>
-            <a:ext cx="1828800" cy="402336"/>
+          <p:cNvPr id="11" name="Text 9"/>
+          <p:cNvSpPr/>
+          <p:nvPr/>
+        </p:nvSpPr>
+        <p:spPr>
+          <a:xfrm>
+            <a:off x="9000439" y="2834640"/>
+            <a:ext cx="2194560" cy="347472"/>
           </a:xfrm>
           <a:prstGeom prst="rect">
             <a:avLst/>
@@ -7869,7 +7610,7 @@
               <a:buNone/>
             </a:pPr>
             <a:r>
-              <a:rPr lang="en-US" sz="1200" b="1" dirty="0">
+              <a:rPr lang="en-US" sz="1200" dirty="0">
                 <a:solidFill>
                   <a:srgbClr val="132A3A"/>
                 </a:solidFill>
@@ -7885,14 +7626,37 @@
       </p:sp>
       <p:sp>
         <p:nvSpPr>
-          <p:cNvPr id="19" name="Text 17"/>
-          <p:cNvSpPr/>
-          <p:nvPr/>
-        </p:nvSpPr>
-        <p:spPr>
-          <a:xfrm>
-            <a:off x="777240" y="4325112"/>
-            <a:ext cx="2743200" cy="402336"/>
+          <p:cNvPr id="12" name="Shape 10"/>
+          <p:cNvSpPr/>
+          <p:nvPr/>
+        </p:nvSpPr>
+        <p:spPr>
+          <a:xfrm>
+            <a:off x="731520" y="3182112"/>
+            <a:ext cx="10600639" cy="0"/>
+          </a:xfrm>
+          <a:prstGeom prst="line">
+            <a:avLst/>
+          </a:prstGeom>
+          <a:noFill/>
+          <a:ln w="6350">
+            <a:solidFill>
+              <a:srgbClr val="E8E8E8"/>
+            </a:solidFill>
+            <a:prstDash val="solid"/>
+          </a:ln>
+        </p:spPr>
+      </p:sp>
+      <p:sp>
+        <p:nvSpPr>
+          <p:cNvPr id="13" name="Text 11"/>
+          <p:cNvSpPr/>
+          <p:nvPr/>
+        </p:nvSpPr>
+        <p:spPr>
+          <a:xfrm>
+            <a:off x="822960" y="3182112"/>
+            <a:ext cx="2743200" cy="347472"/>
           </a:xfrm>
           <a:prstGeom prst="rect">
             <a:avLst/>
@@ -7916,7 +7680,7 @@
                 <a:ea typeface="맑은 고딕" pitchFamily="34" charset="-122"/>
                 <a:cs typeface="맑은 고딕" pitchFamily="34" charset="-120"/>
               </a:rPr>
-              <a:t>매매가</a:t>
+              <a:t>승계 보증금</a:t>
             </a:r>
             <a:endParaRPr lang="en-US" sz="1100" dirty="0"/>
           </a:p>
@@ -7924,14 +7688,14 @@
       </p:sp>
       <p:sp>
         <p:nvSpPr>
-          <p:cNvPr id="20" name="Text 18"/>
-          <p:cNvSpPr/>
-          <p:nvPr/>
-        </p:nvSpPr>
-        <p:spPr>
-          <a:xfrm>
-            <a:off x="9457639" y="4325112"/>
-            <a:ext cx="1828800" cy="402336"/>
+          <p:cNvPr id="14" name="Text 12"/>
+          <p:cNvSpPr/>
+          <p:nvPr/>
+        </p:nvSpPr>
+        <p:spPr>
+          <a:xfrm>
+            <a:off x="9000439" y="3182112"/>
+            <a:ext cx="2194560" cy="347472"/>
           </a:xfrm>
           <a:prstGeom prst="rect">
             <a:avLst/>
@@ -7947,7 +7711,7 @@
               <a:buNone/>
             </a:pPr>
             <a:r>
-              <a:rPr lang="en-US" sz="1200" b="1" dirty="0">
+              <a:rPr lang="en-US" sz="1200" dirty="0">
                 <a:solidFill>
                   <a:srgbClr val="132A3A"/>
                 </a:solidFill>
@@ -7955,7 +7719,7 @@
                 <a:ea typeface="Arial" pitchFamily="34" charset="-122"/>
                 <a:cs typeface="Arial" pitchFamily="34" charset="-120"/>
               </a:rPr>
-              <a:t>760.0억원</a:t>
+              <a:t>0만원</a:t>
             </a:r>
             <a:endParaRPr lang="en-US" sz="1200" dirty="0"/>
           </a:p>
@@ -7963,36 +7727,37 @@
       </p:sp>
       <p:sp>
         <p:nvSpPr>
-          <p:cNvPr id="21" name="Shape 19"/>
-          <p:cNvSpPr/>
-          <p:nvPr/>
-        </p:nvSpPr>
-        <p:spPr>
-          <a:xfrm>
-            <a:off x="685800" y="4837176"/>
-            <a:ext cx="10692079" cy="594360"/>
-          </a:xfrm>
-          <a:prstGeom prst="roundRect">
-            <a:avLst>
-              <a:gd name="adj" fmla="val 9231"/>
-            </a:avLst>
-          </a:prstGeom>
-          <a:solidFill>
-            <a:srgbClr val="132A3A"/>
-          </a:solidFill>
-          <a:ln/>
-        </p:spPr>
-      </p:sp>
-      <p:sp>
-        <p:nvSpPr>
-          <p:cNvPr id="22" name="Text 20"/>
-          <p:cNvSpPr/>
-          <p:nvPr/>
-        </p:nvSpPr>
-        <p:spPr>
-          <a:xfrm>
-            <a:off x="868680" y="4837176"/>
-            <a:ext cx="2286000" cy="594360"/>
+          <p:cNvPr id="15" name="Shape 13"/>
+          <p:cNvSpPr/>
+          <p:nvPr/>
+        </p:nvSpPr>
+        <p:spPr>
+          <a:xfrm>
+            <a:off x="731520" y="3529584"/>
+            <a:ext cx="10600639" cy="0"/>
+          </a:xfrm>
+          <a:prstGeom prst="line">
+            <a:avLst/>
+          </a:prstGeom>
+          <a:noFill/>
+          <a:ln w="6350">
+            <a:solidFill>
+              <a:srgbClr val="E8E8E8"/>
+            </a:solidFill>
+            <a:prstDash val="solid"/>
+          </a:ln>
+        </p:spPr>
+      </p:sp>
+      <p:sp>
+        <p:nvSpPr>
+          <p:cNvPr id="16" name="Text 14"/>
+          <p:cNvSpPr/>
+          <p:nvPr/>
+        </p:nvSpPr>
+        <p:spPr>
+          <a:xfrm>
+            <a:off x="822960" y="3529584"/>
+            <a:ext cx="2743200" cy="347472"/>
           </a:xfrm>
           <a:prstGeom prst="rect">
             <a:avLst/>
@@ -8008,30 +7773,30 @@
               <a:buNone/>
             </a:pPr>
             <a:r>
-              <a:rPr lang="en-US" sz="1200" b="1" dirty="0">
-                <a:solidFill>
-                  <a:srgbClr val="FFFFFF"/>
-                </a:solidFill>
-                <a:latin typeface="맑은 고딕" pitchFamily="34" charset="0"/>
-                <a:ea typeface="맑은 고딕" pitchFamily="34" charset="-122"/>
-                <a:cs typeface="맑은 고딕" pitchFamily="34" charset="-120"/>
-              </a:rPr>
-              <a:t>Cap Rate</a:t>
-            </a:r>
-            <a:endParaRPr lang="en-US" sz="1200" dirty="0"/>
-          </a:p>
-        </p:txBody>
-      </p:sp>
-      <p:sp>
-        <p:nvSpPr>
-          <p:cNvPr id="23" name="Text 21"/>
-          <p:cNvSpPr/>
-          <p:nvPr/>
-        </p:nvSpPr>
-        <p:spPr>
-          <a:xfrm>
-            <a:off x="9183319" y="4837176"/>
-            <a:ext cx="2011680" cy="594360"/>
+              <a:rPr lang="en-US" sz="1100" dirty="0">
+                <a:solidFill>
+                  <a:srgbClr val="5B6B73"/>
+                </a:solidFill>
+                <a:latin typeface="맑은 고딕" pitchFamily="34" charset="0"/>
+                <a:ea typeface="맑은 고딕" pitchFamily="34" charset="-122"/>
+                <a:cs typeface="맑은 고딕" pitchFamily="34" charset="-120"/>
+              </a:rPr>
+              <a:t>매매가</a:t>
+            </a:r>
+            <a:endParaRPr lang="en-US" sz="1100" dirty="0"/>
+          </a:p>
+        </p:txBody>
+      </p:sp>
+      <p:sp>
+        <p:nvSpPr>
+          <p:cNvPr id="17" name="Text 15"/>
+          <p:cNvSpPr/>
+          <p:nvPr/>
+        </p:nvSpPr>
+        <p:spPr>
+          <a:xfrm>
+            <a:off x="9000439" y="3529584"/>
+            <a:ext cx="2194560" cy="347472"/>
           </a:xfrm>
           <a:prstGeom prst="rect">
             <a:avLst/>
@@ -8047,23 +7812,147 @@
               <a:buNone/>
             </a:pPr>
             <a:r>
-              <a:rPr lang="en-US" sz="2200" b="1" dirty="0">
-                <a:solidFill>
-                  <a:srgbClr val="FFFFFF"/>
+              <a:rPr lang="en-US" sz="1200" dirty="0">
+                <a:solidFill>
+                  <a:srgbClr val="132A3A"/>
                 </a:solidFill>
                 <a:latin typeface="Arial" pitchFamily="34" charset="0"/>
                 <a:ea typeface="Arial" pitchFamily="34" charset="-122"/>
                 <a:cs typeface="Arial" pitchFamily="34" charset="-120"/>
               </a:rPr>
-              <a:t>0.00%</a:t>
-            </a:r>
-            <a:endParaRPr lang="en-US" sz="2200" dirty="0"/>
-          </a:p>
-        </p:txBody>
-      </p:sp>
-      <p:sp>
-        <p:nvSpPr>
-          <p:cNvPr id="24" name="Text 22"/>
+              <a:t>760.0억원</a:t>
+            </a:r>
+            <a:endParaRPr lang="en-US" sz="1200" dirty="0"/>
+          </a:p>
+        </p:txBody>
+      </p:sp>
+      <p:sp>
+        <p:nvSpPr>
+          <p:cNvPr id="18" name="Shape 16"/>
+          <p:cNvSpPr/>
+          <p:nvPr/>
+        </p:nvSpPr>
+        <p:spPr>
+          <a:xfrm>
+            <a:off x="731520" y="3877056"/>
+            <a:ext cx="10600639" cy="0"/>
+          </a:xfrm>
+          <a:prstGeom prst="line">
+            <a:avLst/>
+          </a:prstGeom>
+          <a:noFill/>
+          <a:ln w="6350">
+            <a:solidFill>
+              <a:srgbClr val="E8E8E8"/>
+            </a:solidFill>
+            <a:prstDash val="solid"/>
+          </a:ln>
+        </p:spPr>
+      </p:sp>
+      <p:sp>
+        <p:nvSpPr>
+          <p:cNvPr id="19" name="Text 17"/>
+          <p:cNvSpPr/>
+          <p:nvPr/>
+        </p:nvSpPr>
+        <p:spPr>
+          <a:xfrm>
+            <a:off x="822960" y="3877056"/>
+            <a:ext cx="2743200" cy="347472"/>
+          </a:xfrm>
+          <a:prstGeom prst="rect">
+            <a:avLst/>
+          </a:prstGeom>
+          <a:noFill/>
+          <a:ln/>
+        </p:spPr>
+        <p:txBody>
+          <a:bodyPr wrap="square" rtlCol="0" anchor="ctr"/>
+          <a:lstStyle/>
+          <a:p>
+            <a:pPr indent="0" marL="0">
+              <a:buNone/>
+            </a:pPr>
+            <a:r>
+              <a:rPr lang="en-US" sz="1100" dirty="0">
+                <a:solidFill>
+                  <a:srgbClr val="5B6B73"/>
+                </a:solidFill>
+                <a:latin typeface="맑은 고딕" pitchFamily="34" charset="0"/>
+                <a:ea typeface="맑은 고딕" pitchFamily="34" charset="-122"/>
+                <a:cs typeface="맑은 고딕" pitchFamily="34" charset="-120"/>
+              </a:rPr>
+              <a:t>순투자금 (매매가 − 보증금)</a:t>
+            </a:r>
+            <a:endParaRPr lang="en-US" sz="1100" dirty="0"/>
+          </a:p>
+        </p:txBody>
+      </p:sp>
+      <p:sp>
+        <p:nvSpPr>
+          <p:cNvPr id="20" name="Text 18"/>
+          <p:cNvSpPr/>
+          <p:nvPr/>
+        </p:nvSpPr>
+        <p:spPr>
+          <a:xfrm>
+            <a:off x="9000439" y="3877056"/>
+            <a:ext cx="2194560" cy="347472"/>
+          </a:xfrm>
+          <a:prstGeom prst="rect">
+            <a:avLst/>
+          </a:prstGeom>
+          <a:noFill/>
+          <a:ln/>
+        </p:spPr>
+        <p:txBody>
+          <a:bodyPr wrap="square" rtlCol="0" anchor="ctr"/>
+          <a:lstStyle/>
+          <a:p>
+            <a:pPr algn="r" indent="0" marL="0">
+              <a:buNone/>
+            </a:pPr>
+            <a:r>
+              <a:rPr lang="en-US" sz="1200" b="1" dirty="0">
+                <a:solidFill>
+                  <a:srgbClr val="B8860B"/>
+                </a:solidFill>
+                <a:latin typeface="Arial" pitchFamily="34" charset="0"/>
+                <a:ea typeface="Arial" pitchFamily="34" charset="-122"/>
+                <a:cs typeface="Arial" pitchFamily="34" charset="-120"/>
+              </a:rPr>
+              <a:t>760.0억원</a:t>
+            </a:r>
+            <a:endParaRPr lang="en-US" sz="1200" dirty="0"/>
+          </a:p>
+        </p:txBody>
+      </p:sp>
+      <p:sp>
+        <p:nvSpPr>
+          <p:cNvPr id="21" name="Shape 19"/>
+          <p:cNvSpPr/>
+          <p:nvPr/>
+        </p:nvSpPr>
+        <p:spPr>
+          <a:xfrm>
+            <a:off x="731520" y="4224528"/>
+            <a:ext cx="10600639" cy="0"/>
+          </a:xfrm>
+          <a:prstGeom prst="line">
+            <a:avLst/>
+          </a:prstGeom>
+          <a:noFill/>
+          <a:ln w="6350">
+            <a:solidFill>
+              <a:srgbClr val="E8E8E8"/>
+            </a:solidFill>
+            <a:prstDash val="solid"/>
+          </a:ln>
+        </p:spPr>
+      </p:sp>
+      <p:sp>
+        <p:nvSpPr>
+          <p:cNvPr id="22" name="Text 20"/>
           <p:cNvSpPr/>
           <p:nvPr/>
         </p:nvSpPr>
@@ -8102,7 +7991,7 @@
       </p:sp>
       <p:sp>
         <p:nvSpPr>
-          <p:cNvPr id="25" name="Text 23"/>
+          <p:cNvPr id="23" name="Text 21"/>
           <p:cNvSpPr/>
           <p:nvPr/>
         </p:nvSpPr>

</xml_diff>